<commit_message>
Fix courier fleet rental prices to verified rates
</commit_message>
<xml_diff>
--- a/docs/KOG-COURIER-CAREERS-ELECTRIC-FLEET-2026-10-09.pptx
+++ b/docs/KOG-COURIER-CAREERS-ELECTRIC-FLEET-2026-10-09.pptx
@@ -3116,6 +3116,11 @@
               <a:t>Kingdom Organics</a:t>
             </a:r>
           </a:p>
+          <a:p>
+            <a:r>
+              <a:t>Courier Careers</a:t>
+            </a:r>
+          </a:p>
         </p:txBody>
       </p:sp>
       <p:sp>
@@ -3132,12 +3137,6 @@
         <p:txBody>
           <a:bodyPr/>
           <a:lstStyle/>
-          <a:p>
-            <a:pPr/>
-            <a:r>
-              <a:t>Courier Careers</a:t>
-            </a:r>
-          </a:p>
           <a:p>
             <a:pPr/>
             <a:r>
@@ -3609,19 +3608,25 @@
           <a:p>
             <a:pPr/>
             <a:r>
-              <a:t>E-cargo bike: EUR 15 a day, no licence or insurance needed</a:t>
-            </a:r>
-          </a:p>
-          <a:p>
-            <a:pPr/>
-            <a:r>
-              <a:t>BYD ETP3 electric van: EUR 13 a day equivalent, 1,000 kg payload, 280 km range</a:t>
-            </a:r>
-          </a:p>
-          <a:p>
-            <a:pPr/>
-            <a:r>
-              <a:t>Insurance and servicing included in the rental</a:t>
+              <a:t>Cargo e-bike: EUR 12 a day. No licence, no insurance needed</a:t>
+            </a:r>
+          </a:p>
+          <a:p>
+            <a:pPr/>
+            <a:r>
+              <a:t>Electric moped: EUR 20 a day. AM licence required</a:t>
+            </a:r>
+          </a:p>
+          <a:p>
+            <a:pPr/>
+            <a:r>
+              <a:t>Electric van: EUR 35 a day. Full licence required</a:t>
+            </a:r>
+          </a:p>
+          <a:p>
+            <a:pPr/>
+            <a:r>
+              <a:t>Rent is charged only on the days you rent</a:t>
             </a:r>
           </a:p>
           <a:p>
@@ -3688,19 +3693,31 @@
           <a:p>
             <a:pPr/>
             <a:r>
-              <a:t>Own vehicle: EUR 0 cost to you, highest take-home</a:t>
-            </a:r>
-          </a:p>
-          <a:p>
-            <a:pPr/>
-            <a:r>
-              <a:t>Rent e-bike: EUR 15 a day, roughly 4 drops covers it</a:t>
-            </a:r>
-          </a:p>
-          <a:p>
-            <a:pPr/>
-            <a:r>
-              <a:t>Rent electric van: best for between-town runs at EUR 14 per drop</a:t>
+              <a:t>Own vehicle: EUR 0 to you, highest take-home</a:t>
+            </a:r>
+          </a:p>
+          <a:p>
+            <a:pPr/>
+            <a:r>
+              <a:t>Rent e-bike: EUR 12 a day, 2 drops covers it</a:t>
+            </a:r>
+          </a:p>
+          <a:p>
+            <a:pPr/>
+            <a:r>
+              <a:t>Rent moped: EUR 20 a day, 2 to 3 drops covers it</a:t>
+            </a:r>
+          </a:p>
+          <a:p>
+            <a:pPr/>
+            <a:r>
+              <a:t>Rent van: EUR 35 a day, 3 to 4 drops covers it</a:t>
+            </a:r>
+          </a:p>
+          <a:p>
+            <a:pPr/>
+            <a:r>
+              <a:t>Van is best for between-town runs at EUR 14 per drop</a:t>
             </a:r>
           </a:p>
           <a:p>

</xml_diff>